<commit_message>
Use agent-browser as PoC capture path
</commit_message>
<xml_diff>
--- a/artifacts/boi-poc/boi-wiki-poc-executive-brief-with-screenshots.pptx
+++ b/artifacts/boi-poc/boi-wiki-poc-executive-brief-with-screenshots.pptx
@@ -3540,7 +3540,7 @@
             <a:avLst/>
           </a:prstGeom>
           <a:solidFill>
-            <a:srgbClr val="FFF6E2"/>
+            <a:srgbClr val="EBF9F2"/>
           </a:solidFill>
           <a:ln>
             <a:solidFill>
@@ -3585,7 +3585,7 @@
             <a:avLst/>
           </a:prstGeom>
           <a:solidFill>
-            <a:srgbClr val="F0AA30"/>
+            <a:srgbClr val="1F9764"/>
           </a:solidFill>
           <a:ln>
             <a:noFill/>
@@ -3642,7 +3642,7 @@
                 </a:solidFill>
                 <a:latin typeface="Malgun Gothic"/>
               </a:rPr>
-              <a:t>남은 조건</a:t>
+              <a:t>증거 캡처</a:t>
             </a:r>
           </a:p>
         </p:txBody>
@@ -3676,7 +3676,7 @@
                 </a:solidFill>
                 <a:latin typeface="Malgun Gothic"/>
               </a:rPr>
-              <a:t>Chrome localhost 정책 허용 후 실제 핵심 화면 캡처를 슬롯에 삽입</a:t>
+              <a:t>vercel:agent-browser로 핵심 화면 8개를 캡처하고 PPT에 삽입</a:t>
             </a:r>
           </a:p>
         </p:txBody>
@@ -4598,7 +4598,7 @@
                 </a:solidFill>
                 <a:latin typeface="Malgun Gothic"/>
               </a:rPr>
-              <a:t>실제 화면 캡처 삽입 계획</a:t>
+              <a:t>실제 화면 캡처 증거</a:t>
             </a:r>
           </a:p>
         </p:txBody>
@@ -4632,7 +4632,7 @@
                 </a:solidFill>
                 <a:latin typeface="Malgun Gothic"/>
               </a:rPr>
-              <a:t>Chrome 정책 차단 해소 후 핵심 화면 PNG를 이 슬롯에 바로 삽입</a:t>
+              <a:t>vercel:agent-browser로 캡처한 핵심 화면 PNG를 PPT에 삽입</a:t>
             </a:r>
           </a:p>
         </p:txBody>
@@ -8744,7 +8744,7 @@
             <a:avLst/>
           </a:prstGeom>
           <a:solidFill>
-            <a:srgbClr val="FFF6E2"/>
+            <a:srgbClr val="EBF9F2"/>
           </a:solidFill>
           <a:ln>
             <a:solidFill>
@@ -8789,7 +8789,7 @@
             <a:avLst/>
           </a:prstGeom>
           <a:solidFill>
-            <a:srgbClr val="F0AA30"/>
+            <a:srgbClr val="1F9764"/>
           </a:solidFill>
           <a:ln>
             <a:noFill/>
@@ -8880,15 +8880,15 @@
                 </a:solidFill>
                 <a:latin typeface="Malgun Gothic"/>
               </a:rPr>
-              <a:t>대기</a:t>
+              <a:t>완료</a:t>
             </a:r>
             <a:br/>
             <a:r>
-              <a:t>Chrome 자동화가 localhost 접근을 정책 차단</a:t>
+              <a:t>vercel:agent-browser로 BoI Wiki, Langflow, Kafka UI 캡처</a:t>
             </a:r>
             <a:br/>
             <a:r>
-              <a:t>허용 후 실제 PNG 삽입</a:t>
+              <a:t>검증된 PNG 삽입</a:t>
             </a:r>
           </a:p>
         </p:txBody>
@@ -9079,11 +9079,11 @@
             <a:r>
               <a:rPr sz="1400" b="1">
                 <a:solidFill>
-                  <a:srgbClr val="D24C4C"/>
-                </a:solidFill>
-                <a:latin typeface="Malgun Gothic"/>
-              </a:rPr>
-              <a:t>완료 판단은 실제 핵심 화면 캡처 삽입과 PowerPoint에서의 최종 확인 이후에만 가능하다.</a:t>
+                  <a:srgbClr val="1F9764"/>
+                </a:solidFill>
+                <a:latin typeface="Malgun Gothic"/>
+              </a:rPr>
+              <a:t>완료 판단은 readiness gate, 실제 캡처 삽입, artifact-tool PPTX export가 모두 통과했을 때로 둔다.</a:t>
             </a:r>
           </a:p>
         </p:txBody>
@@ -9415,8 +9415,8 @@
         </p:blipFill>
         <p:spPr>
           <a:xfrm>
-            <a:off x="813816" y="2214594"/>
-            <a:ext cx="4818888" cy="2383091"/>
+            <a:off x="1096975" y="1911095"/>
+            <a:ext cx="4252570" cy="2990088"/>
           </a:xfrm>
           <a:prstGeom prst="rect">
             <a:avLst/>
@@ -9552,8 +9552,8 @@
         </p:blipFill>
         <p:spPr>
           <a:xfrm>
-            <a:off x="6117336" y="2214594"/>
-            <a:ext cx="4818888" cy="2383091"/>
+            <a:off x="6400495" y="1911095"/>
+            <a:ext cx="4252570" cy="2990088"/>
           </a:xfrm>
           <a:prstGeom prst="rect">
             <a:avLst/>

</xml_diff>